<commit_message>
fix: adaptar barra lateral al template de 4 tarjetas con geometría dinámica
- Tabla 8 ahora son 4 tarjetas de sección (filas 0-3) + lista en fila 4
- la posición de la lista y el offset del grupo se calculan en runtime,
  así el layout se reajusta solo si cambia el template
- la sección activa conserva su tarjeta y se resalta; la flecha apunta
  exacto a la carrera activa
- ejemplo.xlsx: 4 secciones (incluye Carreras Faco de ejemplo)
</commit_message>
<xml_diff>
--- a/PPTmuestra.pptx
+++ b/PPTmuestra.pptx
@@ -107,6 +107,11 @@
       </a:defRPr>
     </a:lvl9pPr>
   </p:defaultTextStyle>
+  <p:extLst>
+    <p:ext uri="{EFAFB233-063F-42B5-8137-9DF3F51BA10A}">
+      <p15:sldGuideLst xmlns:p15="http://schemas.microsoft.com/office/powerpoint/2012/main"/>
+    </p:ext>
+  </p:extLst>
 </p:presentation>
 </file>
 
@@ -192,7 +197,7 @@
           <a:p>
             <a:fld id="{E2A1ABF3-3341-4E0F-8C88-54B09C2DC80E}" type="datetimeFigureOut">
               <a:rPr lang="es-ES" smtClean="0"/>
-              <a:t>17/06/2026</a:t>
+              <a:t>18/06/2026</a:t>
             </a:fld>
             <a:endParaRPr lang="es-ES"/>
           </a:p>
@@ -735,7 +740,7 @@
           <a:p>
             <a:fld id="{F88BE674-2781-4105-BAF6-3EF7A4EF4036}" type="datetimeFigureOut">
               <a:rPr lang="es-ES" smtClean="0"/>
-              <a:t>17/06/2026</a:t>
+              <a:t>18/06/2026</a:t>
             </a:fld>
             <a:endParaRPr lang="es-ES"/>
           </a:p>
@@ -933,7 +938,7 @@
           <a:p>
             <a:fld id="{F88BE674-2781-4105-BAF6-3EF7A4EF4036}" type="datetimeFigureOut">
               <a:rPr lang="es-ES" smtClean="0"/>
-              <a:t>17/06/2026</a:t>
+              <a:t>18/06/2026</a:t>
             </a:fld>
             <a:endParaRPr lang="es-ES"/>
           </a:p>
@@ -1141,7 +1146,7 @@
           <a:p>
             <a:fld id="{F88BE674-2781-4105-BAF6-3EF7A4EF4036}" type="datetimeFigureOut">
               <a:rPr lang="es-ES" smtClean="0"/>
-              <a:t>17/06/2026</a:t>
+              <a:t>18/06/2026</a:t>
             </a:fld>
             <a:endParaRPr lang="es-ES"/>
           </a:p>
@@ -1339,7 +1344,7 @@
           <a:p>
             <a:fld id="{F88BE674-2781-4105-BAF6-3EF7A4EF4036}" type="datetimeFigureOut">
               <a:rPr lang="es-ES" smtClean="0"/>
-              <a:t>17/06/2026</a:t>
+              <a:t>18/06/2026</a:t>
             </a:fld>
             <a:endParaRPr lang="es-ES"/>
           </a:p>
@@ -1614,7 +1619,7 @@
           <a:p>
             <a:fld id="{F88BE674-2781-4105-BAF6-3EF7A4EF4036}" type="datetimeFigureOut">
               <a:rPr lang="es-ES" smtClean="0"/>
-              <a:t>17/06/2026</a:t>
+              <a:t>18/06/2026</a:t>
             </a:fld>
             <a:endParaRPr lang="es-ES"/>
           </a:p>
@@ -1879,7 +1884,7 @@
           <a:p>
             <a:fld id="{F88BE674-2781-4105-BAF6-3EF7A4EF4036}" type="datetimeFigureOut">
               <a:rPr lang="es-ES" smtClean="0"/>
-              <a:t>17/06/2026</a:t>
+              <a:t>18/06/2026</a:t>
             </a:fld>
             <a:endParaRPr lang="es-ES"/>
           </a:p>
@@ -2291,7 +2296,7 @@
           <a:p>
             <a:fld id="{F88BE674-2781-4105-BAF6-3EF7A4EF4036}" type="datetimeFigureOut">
               <a:rPr lang="es-ES" smtClean="0"/>
-              <a:t>17/06/2026</a:t>
+              <a:t>18/06/2026</a:t>
             </a:fld>
             <a:endParaRPr lang="es-ES"/>
           </a:p>
@@ -2432,7 +2437,7 @@
           <a:p>
             <a:fld id="{F88BE674-2781-4105-BAF6-3EF7A4EF4036}" type="datetimeFigureOut">
               <a:rPr lang="es-ES" smtClean="0"/>
-              <a:t>17/06/2026</a:t>
+              <a:t>18/06/2026</a:t>
             </a:fld>
             <a:endParaRPr lang="es-ES"/>
           </a:p>
@@ -2545,7 +2550,7 @@
           <a:p>
             <a:fld id="{F88BE674-2781-4105-BAF6-3EF7A4EF4036}" type="datetimeFigureOut">
               <a:rPr lang="es-ES" smtClean="0"/>
-              <a:t>17/06/2026</a:t>
+              <a:t>18/06/2026</a:t>
             </a:fld>
             <a:endParaRPr lang="es-ES"/>
           </a:p>
@@ -2856,7 +2861,7 @@
           <a:p>
             <a:fld id="{F88BE674-2781-4105-BAF6-3EF7A4EF4036}" type="datetimeFigureOut">
               <a:rPr lang="es-ES" smtClean="0"/>
-              <a:t>17/06/2026</a:t>
+              <a:t>18/06/2026</a:t>
             </a:fld>
             <a:endParaRPr lang="es-ES"/>
           </a:p>
@@ -3144,7 +3149,7 @@
           <a:p>
             <a:fld id="{F88BE674-2781-4105-BAF6-3EF7A4EF4036}" type="datetimeFigureOut">
               <a:rPr lang="es-ES" smtClean="0"/>
-              <a:t>17/06/2026</a:t>
+              <a:t>18/06/2026</a:t>
             </a:fld>
             <a:endParaRPr lang="es-ES"/>
           </a:p>
@@ -3385,7 +3390,7 @@
           <a:p>
             <a:fld id="{F88BE674-2781-4105-BAF6-3EF7A4EF4036}" type="datetimeFigureOut">
               <a:rPr lang="es-ES" smtClean="0"/>
-              <a:t>17/06/2026</a:t>
+              <a:t>18/06/2026</a:t>
             </a:fld>
             <a:endParaRPr lang="es-ES"/>
           </a:p>
@@ -5869,11 +5874,17 @@
           <p:cNvGraphicFramePr>
             <a:graphicFrameLocks noGrp="1"/>
           </p:cNvGraphicFramePr>
-          <p:nvPr/>
+          <p:nvPr>
+            <p:extLst>
+              <p:ext uri="{D42A27DB-BD31-4B8C-83A1-F6EECF244321}">
+                <p14:modId xmlns:p14="http://schemas.microsoft.com/office/powerpoint/2010/main" val="295213890"/>
+              </p:ext>
+            </p:extLst>
+          </p:nvPr>
         </p:nvGraphicFramePr>
         <p:xfrm>
           <a:off x="237307" y="968381"/>
-          <a:ext cx="1274969" cy="2933140"/>
+          <a:ext cx="1274969" cy="2637049"/>
         </p:xfrm>
         <a:graphic>
           <a:graphicData uri="http://schemas.openxmlformats.org/drawingml/2006/table">
@@ -6089,98 +6100,6 @@
                   </a:ext>
                 </a:extLst>
               </a:tr>
-              <a:tr h="296091">
-                <a:tc>
-                  <a:txBody>
-                    <a:bodyPr/>
-                    <a:lstStyle/>
-                    <a:p>
-                      <a:pPr marL="0" marR="0" lvl="0" indent="0" algn="l" defTabSz="914400" rtl="0" eaLnBrk="1" fontAlgn="auto" latinLnBrk="0" hangingPunct="1">
-                        <a:lnSpc>
-                          <a:spcPct val="100000"/>
-                        </a:lnSpc>
-                        <a:spcBef>
-                          <a:spcPts val="0"/>
-                        </a:spcBef>
-                        <a:spcAft>
-                          <a:spcPts val="0"/>
-                        </a:spcAft>
-                        <a:buClrTx/>
-                        <a:buSzTx/>
-                        <a:buFontTx/>
-                        <a:buNone/>
-                        <a:tabLst/>
-                        <a:defRPr/>
-                      </a:pPr>
-                      <a:r>
-                        <a:rPr lang="es-ES" sz="1050" b="0" kern="1200">
-                          <a:solidFill>
-                            <a:schemeClr val="tx1"/>
-                          </a:solidFill>
-                          <a:latin typeface="+mj-lt"/>
-                          <a:ea typeface="+mn-ea"/>
-                          <a:cs typeface="+mn-cs"/>
-                        </a:rPr>
-                        <a:t>Farm. y Bioq</a:t>
-                      </a:r>
-                      <a:endParaRPr lang="es-PE" sz="1050" b="0" kern="1200">
-                        <a:solidFill>
-                          <a:schemeClr val="tx1"/>
-                        </a:solidFill>
-                        <a:latin typeface="+mj-lt"/>
-                        <a:ea typeface="+mn-ea"/>
-                        <a:cs typeface="+mn-cs"/>
-                      </a:endParaRPr>
-                    </a:p>
-                  </a:txBody>
-                  <a:tcPr>
-                    <a:lnL w="12700" cmpd="sng">
-                      <a:noFill/>
-                    </a:lnL>
-                    <a:lnR w="76200" cap="flat" cmpd="sng" algn="ctr">
-                      <a:noFill/>
-                      <a:prstDash val="solid"/>
-                      <a:round/>
-                      <a:headEnd type="none" w="med" len="med"/>
-                      <a:tailEnd type="none" w="med" len="med"/>
-                    </a:lnR>
-                    <a:lnT w="28575" cap="flat" cmpd="sng" algn="ctr">
-                      <a:solidFill>
-                        <a:schemeClr val="bg1"/>
-                      </a:solidFill>
-                      <a:prstDash val="solid"/>
-                      <a:round/>
-                      <a:headEnd type="none" w="med" len="med"/>
-                      <a:tailEnd type="none" w="med" len="med"/>
-                    </a:lnT>
-                    <a:lnB w="28575" cap="flat" cmpd="sng" algn="ctr">
-                      <a:solidFill>
-                        <a:schemeClr val="bg1"/>
-                      </a:solidFill>
-                      <a:prstDash val="solid"/>
-                      <a:round/>
-                      <a:headEnd type="none" w="med" len="med"/>
-                      <a:tailEnd type="none" w="med" len="med"/>
-                    </a:lnB>
-                    <a:lnTlToBr w="12700" cmpd="sng">
-                      <a:noFill/>
-                      <a:prstDash val="solid"/>
-                    </a:lnTlToBr>
-                    <a:lnBlToTr w="12700" cmpd="sng">
-                      <a:noFill/>
-                      <a:prstDash val="solid"/>
-                    </a:lnBlToTr>
-                    <a:solidFill>
-                      <a:schemeClr val="bg1"/>
-                    </a:solidFill>
-                  </a:tcPr>
-                </a:tc>
-                <a:extLst>
-                  <a:ext uri="{0D108BD9-81ED-4DB2-BD59-A6C34878D82A}">
-                    <a16:rowId xmlns:a16="http://schemas.microsoft.com/office/drawing/2014/main" val="121299358"/>
-                  </a:ext>
-                </a:extLst>
-              </a:tr>
               <a:tr h="438284">
                 <a:tc>
                   <a:txBody>
@@ -6188,7 +6107,7 @@
                     <a:lstStyle/>
                     <a:p>
                       <a:r>
-                        <a:rPr lang="es-PE" sz="1100" b="1">
+                        <a:rPr lang="es-PE" sz="1100" b="1" dirty="0">
                           <a:solidFill>
                             <a:schemeClr val="tx1"/>
                           </a:solidFill>
@@ -6257,7 +6176,7 @@
                         <a:buNone/>
                       </a:pPr>
                       <a:r>
-                        <a:rPr lang="es-MX" sz="1050" b="0" kern="1200">
+                        <a:rPr lang="es-MX" sz="1050" b="0" kern="1200" dirty="0">
                           <a:solidFill>
                             <a:schemeClr val="tx1"/>
                           </a:solidFill>
@@ -6274,7 +6193,7 @@
                         <a:buNone/>
                       </a:pPr>
                       <a:r>
-                        <a:rPr lang="es-MX" sz="1050" b="0" kern="1200">
+                        <a:rPr lang="es-MX" sz="1050" b="0" kern="1200" dirty="0">
                           <a:solidFill>
                             <a:schemeClr val="tx1"/>
                           </a:solidFill>
@@ -6291,7 +6210,7 @@
                         <a:buNone/>
                       </a:pPr>
                       <a:r>
-                        <a:rPr lang="es-MX" sz="1050" b="0" kern="1200">
+                        <a:rPr lang="es-MX" sz="1050" b="0" kern="1200" dirty="0">
                           <a:solidFill>
                             <a:schemeClr val="tx1"/>
                           </a:solidFill>
@@ -6308,7 +6227,7 @@
                         <a:buNone/>
                       </a:pPr>
                       <a:r>
-                        <a:rPr lang="es-MX" sz="1050" b="0" kern="1200">
+                        <a:rPr lang="es-MX" sz="1050" b="0" kern="1200" dirty="0">
                           <a:solidFill>
                             <a:schemeClr val="tx1"/>
                           </a:solidFill>
@@ -6316,7 +6235,29 @@
                           <a:ea typeface="+mn-ea"/>
                           <a:cs typeface="+mn-cs"/>
                         </a:rPr>
-                        <a:t>Ing. Eléct.-Pot.</a:t>
+                        <a:t>Ing. </a:t>
+                      </a:r>
+                      <a:r>
+                        <a:rPr lang="es-MX" sz="1050" b="0" kern="1200" dirty="0" err="1">
+                          <a:solidFill>
+                            <a:schemeClr val="tx1"/>
+                          </a:solidFill>
+                          <a:latin typeface="+mj-lt"/>
+                          <a:ea typeface="+mn-ea"/>
+                          <a:cs typeface="+mn-cs"/>
+                        </a:rPr>
+                        <a:t>Eléct</a:t>
+                      </a:r>
+                      <a:r>
+                        <a:rPr lang="es-MX" sz="1050" b="0" kern="1200" dirty="0">
+                          <a:solidFill>
+                            <a:schemeClr val="tx1"/>
+                          </a:solidFill>
+                          <a:latin typeface="+mj-lt"/>
+                          <a:ea typeface="+mn-ea"/>
+                          <a:cs typeface="+mn-cs"/>
+                        </a:rPr>
+                        <a:t>.-Pot.</a:t>
                       </a:r>
                     </a:p>
                     <a:p>
@@ -6325,7 +6266,7 @@
                         <a:buNone/>
                       </a:pPr>
                       <a:r>
-                        <a:rPr lang="es-MX" sz="1050" b="0" kern="1200">
+                        <a:rPr lang="es-MX" sz="1050" b="0" kern="1200" dirty="0">
                           <a:solidFill>
                             <a:schemeClr val="tx1"/>
                           </a:solidFill>
@@ -6333,7 +6274,51 @@
                           <a:ea typeface="+mn-ea"/>
                           <a:cs typeface="+mn-cs"/>
                         </a:rPr>
-                        <a:t>Ing. Seg. Ind.-Min.</a:t>
+                        <a:t>Ing. </a:t>
+                      </a:r>
+                      <a:r>
+                        <a:rPr lang="es-MX" sz="1050" b="0" kern="1200" dirty="0" err="1">
+                          <a:solidFill>
+                            <a:schemeClr val="tx1"/>
+                          </a:solidFill>
+                          <a:latin typeface="+mj-lt"/>
+                          <a:ea typeface="+mn-ea"/>
+                          <a:cs typeface="+mn-cs"/>
+                        </a:rPr>
+                        <a:t>Seg</a:t>
+                      </a:r>
+                      <a:r>
+                        <a:rPr lang="es-MX" sz="1050" b="0" kern="1200" dirty="0">
+                          <a:solidFill>
+                            <a:schemeClr val="tx1"/>
+                          </a:solidFill>
+                          <a:latin typeface="+mj-lt"/>
+                          <a:ea typeface="+mn-ea"/>
+                          <a:cs typeface="+mn-cs"/>
+                        </a:rPr>
+                        <a:t>. </a:t>
+                      </a:r>
+                      <a:r>
+                        <a:rPr lang="es-MX" sz="1050" b="0" kern="1200" dirty="0" err="1">
+                          <a:solidFill>
+                            <a:schemeClr val="tx1"/>
+                          </a:solidFill>
+                          <a:latin typeface="+mj-lt"/>
+                          <a:ea typeface="+mn-ea"/>
+                          <a:cs typeface="+mn-cs"/>
+                        </a:rPr>
+                        <a:t>Ind</a:t>
+                      </a:r>
+                      <a:r>
+                        <a:rPr lang="es-MX" sz="1050" b="0" kern="1200" dirty="0">
+                          <a:solidFill>
+                            <a:schemeClr val="tx1"/>
+                          </a:solidFill>
+                          <a:latin typeface="+mj-lt"/>
+                          <a:ea typeface="+mn-ea"/>
+                          <a:cs typeface="+mn-cs"/>
+                        </a:rPr>
+                        <a:t>.-Min.</a:t>
                       </a:r>
                     </a:p>
                     <a:p>
@@ -6342,7 +6327,7 @@
                         <a:buNone/>
                       </a:pPr>
                       <a:r>
-                        <a:rPr lang="es-MX" sz="1050" b="0" kern="1200">
+                        <a:rPr lang="es-MX" sz="1050" b="0" kern="1200" dirty="0" err="1">
                           <a:solidFill>
                             <a:schemeClr val="tx1"/>
                           </a:solidFill>
@@ -6350,7 +6335,18 @@
                           <a:ea typeface="+mn-ea"/>
                           <a:cs typeface="+mn-cs"/>
                         </a:rPr>
-                        <a:t>Dis. Interiores</a:t>
+                        <a:t>Dis</a:t>
+                      </a:r>
+                      <a:r>
+                        <a:rPr lang="es-MX" sz="1050" b="0" kern="1200" dirty="0">
+                          <a:solidFill>
+                            <a:schemeClr val="tx1"/>
+                          </a:solidFill>
+                          <a:latin typeface="+mj-lt"/>
+                          <a:ea typeface="+mn-ea"/>
+                          <a:cs typeface="+mn-cs"/>
+                        </a:rPr>
+                        <a:t>. Interiores</a:t>
                       </a:r>
                     </a:p>
                     <a:p>
@@ -6359,7 +6355,7 @@
                         <a:buNone/>
                       </a:pPr>
                       <a:r>
-                        <a:rPr lang="es-MX" sz="1050" b="0" kern="1200">
+                        <a:rPr lang="es-MX" sz="1050" b="0" kern="1200" dirty="0">
                           <a:solidFill>
                             <a:schemeClr val="tx1"/>
                           </a:solidFill>
@@ -6376,7 +6372,7 @@
                         <a:buNone/>
                       </a:pPr>
                       <a:r>
-                        <a:rPr lang="es-MX" sz="1050" b="0" kern="1200">
+                        <a:rPr lang="es-MX" sz="1050" b="0" kern="1200" dirty="0">
                           <a:solidFill>
                             <a:schemeClr val="tx1"/>
                           </a:solidFill>
@@ -6444,7 +6440,7 @@
         </p:nvGrpSpPr>
         <p:grpSpPr>
           <a:xfrm>
-            <a:off x="232287" y="2655830"/>
+            <a:off x="241812" y="2537427"/>
             <a:ext cx="1554747" cy="318221"/>
             <a:chOff x="232287" y="2768379"/>
             <a:chExt cx="1554747" cy="318221"/>

</xml_diff>